<commit_message>
feat: update UI design documents and remove temporary files
</commit_message>
<xml_diff>
--- a/docs/UI-Design.pptx
+++ b/docs/UI-Design.pptx
@@ -3650,6 +3650,36 @@
           <a:chExt cx="0" cy="0"/>
         </a:xfrm>
       </p:grpSpPr>
+      <p:pic>
+        <p:nvPicPr>
+          <p:cNvPr id="10" name="図 9">
+            <a:extLst>
+              <a:ext uri="{FF2B5EF4-FFF2-40B4-BE49-F238E27FC236}">
+                <a16:creationId xmlns:a16="http://schemas.microsoft.com/office/drawing/2014/main" id="{428CB256-F8C7-3A98-5142-F5CCC5A8915C}"/>
+              </a:ext>
+            </a:extLst>
+          </p:cNvPr>
+          <p:cNvPicPr>
+            <a:picLocks noChangeAspect="1"/>
+          </p:cNvPicPr>
+          <p:nvPr/>
+        </p:nvPicPr>
+        <p:blipFill>
+          <a:blip r:embed="rId2"/>
+          <a:stretch>
+            <a:fillRect/>
+          </a:stretch>
+        </p:blipFill>
+        <p:spPr>
+          <a:xfrm>
+            <a:off x="1561475" y="1561672"/>
+            <a:ext cx="6792273" cy="571580"/>
+          </a:xfrm>
+          <a:prstGeom prst="rect">
+            <a:avLst/>
+          </a:prstGeom>
+        </p:spPr>
+      </p:pic>
       <p:sp>
         <p:nvSpPr>
           <p:cNvPr id="4" name="タイトル 3">
@@ -3674,6 +3704,18 @@
           <a:lstStyle/>
           <a:p>
             <a:r>
+              <a:rPr lang="en-US" altLang="ja-JP" dirty="0"/>
+              <a:t>TEST</a:t>
+            </a:r>
+            <a:r>
+              <a:rPr lang="ja-JP" altLang="en-US" dirty="0"/>
+              <a:t> ページ</a:t>
+            </a:r>
+            <a:r>
+              <a:rPr lang="en-US" altLang="ja-JP" dirty="0"/>
+              <a:t>: </a:t>
+            </a:r>
+            <a:r>
               <a:rPr lang="ja-JP" altLang="en-US" dirty="0"/>
               <a:t>初期画面</a:t>
             </a:r>
@@ -3695,14 +3737,14 @@
           <p:nvPr>
             <p:extLst>
               <p:ext uri="{D42A27DB-BD31-4B8C-83A1-F6EECF244321}">
-                <p14:modId xmlns:p14="http://schemas.microsoft.com/office/powerpoint/2010/main" val="336718845"/>
+                <p14:modId xmlns:p14="http://schemas.microsoft.com/office/powerpoint/2010/main" val="3586469734"/>
               </p:ext>
             </p:extLst>
           </p:nvPr>
         </p:nvGraphicFramePr>
         <p:xfrm>
-          <a:off x="1574800" y="2494324"/>
-          <a:ext cx="8712200" cy="2595880"/>
+          <a:off x="1574800" y="2216926"/>
+          <a:ext cx="8712200" cy="3708400"/>
         </p:xfrm>
         <a:graphic>
           <a:graphicData uri="http://schemas.openxmlformats.org/drawingml/2006/table">
@@ -4368,10 +4410,501 @@
                   </a:ext>
                 </a:extLst>
               </a:tr>
+              <a:tr h="370840">
+                <a:tc>
+                  <a:txBody>
+                    <a:bodyPr/>
+                    <a:lstStyle/>
+                    <a:p>
+                      <a:pPr algn="ctr"/>
+                      <a:r>
+                        <a:rPr kumimoji="1" lang="en-US" altLang="ja-JP" dirty="0"/>
+                        <a:t>7</a:t>
+                      </a:r>
+                      <a:endParaRPr kumimoji="1" lang="ja-JP" altLang="en-US" dirty="0"/>
+                    </a:p>
+                  </a:txBody>
+                  <a:tcPr/>
+                </a:tc>
+                <a:tc>
+                  <a:txBody>
+                    <a:bodyPr/>
+                    <a:lstStyle/>
+                    <a:p>
+                      <a:pPr marL="0" marR="0" lvl="0" indent="0" algn="l" defTabSz="914400" rtl="0" eaLnBrk="1" fontAlgn="auto" latinLnBrk="0" hangingPunct="1">
+                        <a:lnSpc>
+                          <a:spcPct val="100000"/>
+                        </a:lnSpc>
+                        <a:spcBef>
+                          <a:spcPts val="0"/>
+                        </a:spcBef>
+                        <a:spcAft>
+                          <a:spcPts val="0"/>
+                        </a:spcAft>
+                        <a:buClrTx/>
+                        <a:buSzTx/>
+                        <a:buFontTx/>
+                        <a:buNone/>
+                        <a:tabLst/>
+                        <a:defRPr/>
+                      </a:pPr>
+                      <a:r>
+                        <a:rPr kumimoji="1" lang="ja-JP" altLang="en-US" sz="1800" b="0" kern="1200" dirty="0">
+                          <a:solidFill>
+                            <a:schemeClr val="dk1"/>
+                          </a:solidFill>
+                          <a:effectLst/>
+                          <a:latin typeface="+mn-lt"/>
+                          <a:ea typeface="+mn-ea"/>
+                          <a:cs typeface="+mn-cs"/>
+                        </a:rPr>
+                        <a:t>マッチング問題 </a:t>
+                      </a:r>
+                      <a:r>
+                        <a:rPr kumimoji="1" lang="en-US" altLang="ja-JP" sz="1800" b="0" kern="1200" dirty="0">
+                          <a:solidFill>
+                            <a:schemeClr val="dk1"/>
+                          </a:solidFill>
+                          <a:effectLst/>
+                          <a:latin typeface="+mn-lt"/>
+                          <a:ea typeface="+mn-ea"/>
+                          <a:cs typeface="+mn-cs"/>
+                        </a:rPr>
+                        <a:t>#2</a:t>
+                      </a:r>
+                      <a:endParaRPr kumimoji="1" lang="ja-JP" altLang="en-US" sz="1800" b="0" kern="1200" dirty="0">
+                        <a:solidFill>
+                          <a:schemeClr val="dk1"/>
+                        </a:solidFill>
+                        <a:effectLst/>
+                        <a:latin typeface="+mn-lt"/>
+                        <a:ea typeface="+mn-ea"/>
+                        <a:cs typeface="+mn-cs"/>
+                      </a:endParaRPr>
+                    </a:p>
+                  </a:txBody>
+                  <a:tcPr/>
+                </a:tc>
+                <a:tc>
+                  <a:txBody>
+                    <a:bodyPr/>
+                    <a:lstStyle/>
+                    <a:p>
+                      <a:pPr marL="0" marR="0" lvl="0" indent="0" algn="l" defTabSz="914400" rtl="0" eaLnBrk="1" fontAlgn="auto" latinLnBrk="0" hangingPunct="1">
+                        <a:lnSpc>
+                          <a:spcPct val="100000"/>
+                        </a:lnSpc>
+                        <a:spcBef>
+                          <a:spcPts val="0"/>
+                        </a:spcBef>
+                        <a:spcAft>
+                          <a:spcPts val="0"/>
+                        </a:spcAft>
+                        <a:buClrTx/>
+                        <a:buSzTx/>
+                        <a:buFontTx/>
+                        <a:buNone/>
+                        <a:tabLst/>
+                        <a:defRPr/>
+                      </a:pPr>
+                      <a:r>
+                        <a:rPr kumimoji="1" lang="en-US" altLang="ja-JP" sz="1800" b="0" kern="1200" dirty="0">
+                          <a:solidFill>
+                            <a:schemeClr val="dk1"/>
+                          </a:solidFill>
+                          <a:effectLst/>
+                          <a:latin typeface="+mn-lt"/>
+                          <a:ea typeface="+mn-ea"/>
+                          <a:cs typeface="+mn-cs"/>
+                        </a:rPr>
+                        <a:t>match-interaction</a:t>
+                      </a:r>
+                    </a:p>
+                  </a:txBody>
+                  <a:tcPr/>
+                </a:tc>
+                <a:extLst>
+                  <a:ext uri="{0D108BD9-81ED-4DB2-BD59-A6C34878D82A}">
+                    <a16:rowId xmlns:a16="http://schemas.microsoft.com/office/drawing/2014/main" val="3965769796"/>
+                  </a:ext>
+                </a:extLst>
+              </a:tr>
+              <a:tr h="370840">
+                <a:tc>
+                  <a:txBody>
+                    <a:bodyPr/>
+                    <a:lstStyle/>
+                    <a:p>
+                      <a:pPr algn="ctr"/>
+                      <a:r>
+                        <a:rPr kumimoji="1" lang="en-US" altLang="ja-JP" dirty="0"/>
+                        <a:t>8</a:t>
+                      </a:r>
+                      <a:endParaRPr kumimoji="1" lang="ja-JP" altLang="en-US" dirty="0"/>
+                    </a:p>
+                  </a:txBody>
+                  <a:tcPr/>
+                </a:tc>
+                <a:tc>
+                  <a:txBody>
+                    <a:bodyPr/>
+                    <a:lstStyle/>
+                    <a:p>
+                      <a:pPr marL="0" marR="0" lvl="0" indent="0" algn="l" defTabSz="914400" rtl="0" eaLnBrk="1" fontAlgn="auto" latinLnBrk="0" hangingPunct="1">
+                        <a:lnSpc>
+                          <a:spcPct val="100000"/>
+                        </a:lnSpc>
+                        <a:spcBef>
+                          <a:spcPts val="0"/>
+                        </a:spcBef>
+                        <a:spcAft>
+                          <a:spcPts val="0"/>
+                        </a:spcAft>
+                        <a:buClrTx/>
+                        <a:buSzTx/>
+                        <a:buFontTx/>
+                        <a:buNone/>
+                        <a:tabLst/>
+                        <a:defRPr/>
+                      </a:pPr>
+                      <a:r>
+                        <a:rPr kumimoji="1" lang="ja-JP" altLang="en-US" sz="1800" b="0" kern="1200" dirty="0">
+                          <a:solidFill>
+                            <a:schemeClr val="dk1"/>
+                          </a:solidFill>
+                          <a:effectLst/>
+                          <a:latin typeface="+mn-lt"/>
+                          <a:ea typeface="+mn-ea"/>
+                          <a:cs typeface="+mn-cs"/>
+                        </a:rPr>
+                        <a:t>インライン選択問題</a:t>
+                      </a:r>
+                      <a:r>
+                        <a:rPr kumimoji="1" lang="en-US" altLang="ja-JP" sz="1800" b="0" kern="1200" dirty="0">
+                          <a:solidFill>
+                            <a:schemeClr val="dk1"/>
+                          </a:solidFill>
+                          <a:effectLst/>
+                          <a:latin typeface="+mn-lt"/>
+                          <a:ea typeface="+mn-ea"/>
+                          <a:cs typeface="+mn-cs"/>
+                        </a:rPr>
+                        <a:t>(</a:t>
+                      </a:r>
+                      <a:r>
+                        <a:rPr kumimoji="1" lang="ja-JP" altLang="en-US" sz="1800" b="0" kern="1200" dirty="0">
+                          <a:solidFill>
+                            <a:schemeClr val="dk1"/>
+                          </a:solidFill>
+                          <a:effectLst/>
+                          <a:latin typeface="+mn-lt"/>
+                          <a:ea typeface="+mn-ea"/>
+                          <a:cs typeface="+mn-cs"/>
+                        </a:rPr>
+                        <a:t>縦書き</a:t>
+                      </a:r>
+                      <a:r>
+                        <a:rPr kumimoji="1" lang="en-US" altLang="ja-JP" sz="1800" b="0" kern="1200" dirty="0">
+                          <a:solidFill>
+                            <a:schemeClr val="dk1"/>
+                          </a:solidFill>
+                          <a:effectLst/>
+                          <a:latin typeface="+mn-lt"/>
+                          <a:ea typeface="+mn-ea"/>
+                          <a:cs typeface="+mn-cs"/>
+                        </a:rPr>
+                        <a:t>)</a:t>
+                      </a:r>
+                      <a:endParaRPr kumimoji="1" lang="ja-JP" altLang="en-US" sz="1800" b="0" kern="1200" dirty="0">
+                        <a:solidFill>
+                          <a:schemeClr val="dk1"/>
+                        </a:solidFill>
+                        <a:effectLst/>
+                        <a:latin typeface="+mn-lt"/>
+                        <a:ea typeface="+mn-ea"/>
+                        <a:cs typeface="+mn-cs"/>
+                      </a:endParaRPr>
+                    </a:p>
+                  </a:txBody>
+                  <a:tcPr/>
+                </a:tc>
+                <a:tc>
+                  <a:txBody>
+                    <a:bodyPr/>
+                    <a:lstStyle/>
+                    <a:p>
+                      <a:pPr marL="0" marR="0" lvl="0" indent="0" algn="l" defTabSz="914400" rtl="0" eaLnBrk="1" fontAlgn="auto" latinLnBrk="0" hangingPunct="1">
+                        <a:lnSpc>
+                          <a:spcPct val="100000"/>
+                        </a:lnSpc>
+                        <a:spcBef>
+                          <a:spcPts val="0"/>
+                        </a:spcBef>
+                        <a:spcAft>
+                          <a:spcPts val="0"/>
+                        </a:spcAft>
+                        <a:buClrTx/>
+                        <a:buSzTx/>
+                        <a:buFontTx/>
+                        <a:buNone/>
+                        <a:tabLst/>
+                        <a:defRPr/>
+                      </a:pPr>
+                      <a:r>
+                        <a:rPr kumimoji="1" lang="en-US" altLang="ja-JP" sz="1800" b="0" kern="1200" dirty="0">
+                          <a:solidFill>
+                            <a:schemeClr val="dk1"/>
+                          </a:solidFill>
+                          <a:effectLst/>
+                          <a:latin typeface="+mn-lt"/>
+                          <a:ea typeface="+mn-ea"/>
+                          <a:cs typeface="+mn-cs"/>
+                        </a:rPr>
+                        <a:t>inline-choice-interaction</a:t>
+                      </a:r>
+                    </a:p>
+                  </a:txBody>
+                  <a:tcPr/>
+                </a:tc>
+                <a:extLst>
+                  <a:ext uri="{0D108BD9-81ED-4DB2-BD59-A6C34878D82A}">
+                    <a16:rowId xmlns:a16="http://schemas.microsoft.com/office/drawing/2014/main" val="4111058625"/>
+                  </a:ext>
+                </a:extLst>
+              </a:tr>
+              <a:tr h="370840">
+                <a:tc>
+                  <a:txBody>
+                    <a:bodyPr/>
+                    <a:lstStyle/>
+                    <a:p>
+                      <a:pPr algn="ctr"/>
+                      <a:r>
+                        <a:rPr kumimoji="1" lang="en-US" altLang="ja-JP" dirty="0"/>
+                        <a:t>9</a:t>
+                      </a:r>
+                      <a:endParaRPr kumimoji="1" lang="ja-JP" altLang="en-US" dirty="0"/>
+                    </a:p>
+                  </a:txBody>
+                  <a:tcPr/>
+                </a:tc>
+                <a:tc>
+                  <a:txBody>
+                    <a:bodyPr/>
+                    <a:lstStyle/>
+                    <a:p>
+                      <a:pPr marL="0" marR="0" lvl="0" indent="0" algn="l" defTabSz="914400" rtl="0" eaLnBrk="1" fontAlgn="auto" latinLnBrk="0" hangingPunct="1">
+                        <a:lnSpc>
+                          <a:spcPct val="100000"/>
+                        </a:lnSpc>
+                        <a:spcBef>
+                          <a:spcPts val="0"/>
+                        </a:spcBef>
+                        <a:spcAft>
+                          <a:spcPts val="0"/>
+                        </a:spcAft>
+                        <a:buClrTx/>
+                        <a:buSzTx/>
+                        <a:buFontTx/>
+                        <a:buNone/>
+                        <a:tabLst/>
+                        <a:defRPr/>
+                      </a:pPr>
+                      <a:r>
+                        <a:rPr kumimoji="1" lang="ja-JP" altLang="en-US" sz="1800" b="0" kern="1200" dirty="0">
+                          <a:solidFill>
+                            <a:schemeClr val="dk1"/>
+                          </a:solidFill>
+                          <a:effectLst/>
+                          <a:latin typeface="+mn-lt"/>
+                          <a:ea typeface="+mn-ea"/>
+                          <a:cs typeface="+mn-cs"/>
+                        </a:rPr>
+                        <a:t>テキスト入力問題</a:t>
+                      </a:r>
+                      <a:r>
+                        <a:rPr kumimoji="1" lang="en-US" altLang="ja-JP" sz="1800" b="0" kern="1200" dirty="0">
+                          <a:solidFill>
+                            <a:schemeClr val="dk1"/>
+                          </a:solidFill>
+                          <a:effectLst/>
+                          <a:latin typeface="+mn-lt"/>
+                          <a:ea typeface="+mn-ea"/>
+                          <a:cs typeface="+mn-cs"/>
+                        </a:rPr>
+                        <a:t>(</a:t>
+                      </a:r>
+                      <a:r>
+                        <a:rPr kumimoji="1" lang="ja-JP" altLang="en-US" sz="1800" b="0" kern="1200" dirty="0">
+                          <a:solidFill>
+                            <a:schemeClr val="dk1"/>
+                          </a:solidFill>
+                          <a:effectLst/>
+                          <a:latin typeface="+mn-lt"/>
+                          <a:ea typeface="+mn-ea"/>
+                          <a:cs typeface="+mn-cs"/>
+                        </a:rPr>
+                        <a:t>縦書き</a:t>
+                      </a:r>
+                      <a:r>
+                        <a:rPr kumimoji="1" lang="en-US" altLang="ja-JP" sz="1800" b="0" kern="1200" dirty="0">
+                          <a:solidFill>
+                            <a:schemeClr val="dk1"/>
+                          </a:solidFill>
+                          <a:effectLst/>
+                          <a:latin typeface="+mn-lt"/>
+                          <a:ea typeface="+mn-ea"/>
+                          <a:cs typeface="+mn-cs"/>
+                        </a:rPr>
+                        <a:t>)</a:t>
+                      </a:r>
+                      <a:endParaRPr kumimoji="1" lang="ja-JP" altLang="en-US" sz="1800" b="0" kern="1200" dirty="0">
+                        <a:solidFill>
+                          <a:schemeClr val="dk1"/>
+                        </a:solidFill>
+                        <a:effectLst/>
+                        <a:latin typeface="+mn-lt"/>
+                        <a:ea typeface="+mn-ea"/>
+                        <a:cs typeface="+mn-cs"/>
+                      </a:endParaRPr>
+                    </a:p>
+                  </a:txBody>
+                  <a:tcPr/>
+                </a:tc>
+                <a:tc>
+                  <a:txBody>
+                    <a:bodyPr/>
+                    <a:lstStyle/>
+                    <a:p>
+                      <a:pPr marL="0" marR="0" lvl="0" indent="0" algn="l" defTabSz="914400" rtl="0" eaLnBrk="1" fontAlgn="auto" latinLnBrk="0" hangingPunct="1">
+                        <a:lnSpc>
+                          <a:spcPct val="100000"/>
+                        </a:lnSpc>
+                        <a:spcBef>
+                          <a:spcPts val="0"/>
+                        </a:spcBef>
+                        <a:spcAft>
+                          <a:spcPts val="0"/>
+                        </a:spcAft>
+                        <a:buClrTx/>
+                        <a:buSzTx/>
+                        <a:buFontTx/>
+                        <a:buNone/>
+                        <a:tabLst/>
+                        <a:defRPr/>
+                      </a:pPr>
+                      <a:r>
+                        <a:rPr kumimoji="1" lang="en-US" altLang="ja-JP" sz="1800" b="0" kern="1200" dirty="0">
+                          <a:solidFill>
+                            <a:schemeClr val="dk1"/>
+                          </a:solidFill>
+                          <a:effectLst/>
+                          <a:latin typeface="+mn-lt"/>
+                          <a:ea typeface="+mn-ea"/>
+                          <a:cs typeface="+mn-cs"/>
+                        </a:rPr>
+                        <a:t>text-entry-interaction</a:t>
+                      </a:r>
+                    </a:p>
+                  </a:txBody>
+                  <a:tcPr/>
+                </a:tc>
+                <a:extLst>
+                  <a:ext uri="{0D108BD9-81ED-4DB2-BD59-A6C34878D82A}">
+                    <a16:rowId xmlns:a16="http://schemas.microsoft.com/office/drawing/2014/main" val="4102092691"/>
+                  </a:ext>
+                </a:extLst>
+              </a:tr>
             </a:tbl>
           </a:graphicData>
         </a:graphic>
       </p:graphicFrame>
+      <p:pic>
+        <p:nvPicPr>
+          <p:cNvPr id="9" name="図 8">
+            <a:extLst>
+              <a:ext uri="{FF2B5EF4-FFF2-40B4-BE49-F238E27FC236}">
+                <a16:creationId xmlns:a16="http://schemas.microsoft.com/office/drawing/2014/main" id="{954D02A2-D09B-57F6-945B-D983CBC836D6}"/>
+              </a:ext>
+            </a:extLst>
+          </p:cNvPr>
+          <p:cNvPicPr>
+            <a:picLocks noChangeAspect="1"/>
+          </p:cNvPicPr>
+          <p:nvPr/>
+        </p:nvPicPr>
+        <p:blipFill>
+          <a:blip r:embed="rId2"/>
+          <a:stretch>
+            <a:fillRect/>
+          </a:stretch>
+        </p:blipFill>
+        <p:spPr>
+          <a:xfrm>
+            <a:off x="3494727" y="1561672"/>
+            <a:ext cx="6792273" cy="571580"/>
+          </a:xfrm>
+          <a:prstGeom prst="rect">
+            <a:avLst/>
+          </a:prstGeom>
+        </p:spPr>
+      </p:pic>
+      <p:sp>
+        <p:nvSpPr>
+          <p:cNvPr id="2" name="四角形: 角を丸くする 1">
+            <a:extLst>
+              <a:ext uri="{FF2B5EF4-FFF2-40B4-BE49-F238E27FC236}">
+                <a16:creationId xmlns:a16="http://schemas.microsoft.com/office/drawing/2014/main" id="{613AADAC-8046-6556-EA99-EB4C47D1DBED}"/>
+              </a:ext>
+            </a:extLst>
+          </p:cNvPr>
+          <p:cNvSpPr/>
+          <p:nvPr/>
+        </p:nvSpPr>
+        <p:spPr>
+          <a:xfrm>
+            <a:off x="1736992" y="1652396"/>
+            <a:ext cx="1582218" cy="390132"/>
+          </a:xfrm>
+          <a:prstGeom prst="roundRect">
+            <a:avLst/>
+          </a:prstGeom>
+          <a:solidFill>
+            <a:schemeClr val="bg1"/>
+          </a:solidFill>
+        </p:spPr>
+        <p:style>
+          <a:lnRef idx="2">
+            <a:schemeClr val="accent1">
+              <a:shade val="15000"/>
+            </a:schemeClr>
+          </a:lnRef>
+          <a:fillRef idx="1">
+            <a:schemeClr val="accent1"/>
+          </a:fillRef>
+          <a:effectRef idx="0">
+            <a:schemeClr val="accent1"/>
+          </a:effectRef>
+          <a:fontRef idx="minor">
+            <a:schemeClr val="lt1"/>
+          </a:fontRef>
+        </p:style>
+        <p:txBody>
+          <a:bodyPr rtlCol="0" anchor="ctr"/>
+          <a:lstStyle/>
+          <a:p>
+            <a:pPr algn="ctr"/>
+            <a:r>
+              <a:rPr kumimoji="1" lang="ja-JP" altLang="en-US" dirty="0">
+                <a:solidFill>
+                  <a:schemeClr val="tx1"/>
+                </a:solidFill>
+              </a:rPr>
+              <a:t>はじめる</a:t>
+            </a:r>
+          </a:p>
+        </p:txBody>
+      </p:sp>
     </p:spTree>
     <p:extLst>
       <p:ext uri="{BB962C8B-B14F-4D97-AF65-F5344CB8AC3E}">
@@ -4479,14 +5012,15 @@
         </p:nvPicPr>
         <p:blipFill>
           <a:blip r:embed="rId3"/>
+          <a:srcRect t="11079"/>
           <a:stretch>
             <a:fillRect/>
           </a:stretch>
         </p:blipFill>
         <p:spPr>
           <a:xfrm>
-            <a:off x="1551941" y="647312"/>
-            <a:ext cx="9088118" cy="5563376"/>
+            <a:off x="1551941" y="1263720"/>
+            <a:ext cx="9088118" cy="4946967"/>
           </a:xfrm>
           <a:prstGeom prst="rect">
             <a:avLst/>
@@ -4963,14 +5497,14 @@
           <p:nvPr>
             <p:extLst>
               <p:ext uri="{D42A27DB-BD31-4B8C-83A1-F6EECF244321}">
-                <p14:modId xmlns:p14="http://schemas.microsoft.com/office/powerpoint/2010/main" val="3410450057"/>
+                <p14:modId xmlns:p14="http://schemas.microsoft.com/office/powerpoint/2010/main" val="2081313757"/>
               </p:ext>
             </p:extLst>
           </p:nvPr>
         </p:nvGraphicFramePr>
         <p:xfrm>
-          <a:off x="1574800" y="3069675"/>
-          <a:ext cx="8712200" cy="2595880"/>
+          <a:off x="1574800" y="2627888"/>
+          <a:ext cx="8712201" cy="3708400"/>
         </p:xfrm>
         <a:graphic>
           <a:graphicData uri="http://schemas.openxmlformats.org/drawingml/2006/table">
@@ -4979,21 +5513,28 @@
                 <a:tableStyleId>{8EC20E35-A176-4012-BC5E-935CFFF8708E}</a:tableStyleId>
               </a:tblPr>
               <a:tblGrid>
-                <a:gridCol w="602916">
+                <a:gridCol w="438503">
                   <a:extLst>
                     <a:ext uri="{9D8B030D-6E8A-4147-A177-3AD203B41FA5}">
                       <a16:colId xmlns:a16="http://schemas.microsoft.com/office/drawing/2014/main" val="3897167719"/>
                     </a:ext>
                   </a:extLst>
                 </a:gridCol>
-                <a:gridCol w="4842710">
+                <a:gridCol w="3522118">
                   <a:extLst>
                     <a:ext uri="{9D8B030D-6E8A-4147-A177-3AD203B41FA5}">
                       <a16:colId xmlns:a16="http://schemas.microsoft.com/office/drawing/2014/main" val="2763979411"/>
                     </a:ext>
                   </a:extLst>
                 </a:gridCol>
-                <a:gridCol w="3266574">
+                <a:gridCol w="2375790">
+                  <a:extLst>
+                    <a:ext uri="{9D8B030D-6E8A-4147-A177-3AD203B41FA5}">
+                      <a16:colId xmlns:a16="http://schemas.microsoft.com/office/drawing/2014/main" val="2178836827"/>
+                    </a:ext>
+                  </a:extLst>
+                </a:gridCol>
+                <a:gridCol w="2375790">
                   <a:extLst>
                     <a:ext uri="{9D8B030D-6E8A-4147-A177-3AD203B41FA5}">
                       <a16:colId xmlns:a16="http://schemas.microsoft.com/office/drawing/2014/main" val="4141302892"/>
@@ -5024,6 +5565,19 @@
                       <a:r>
                         <a:rPr kumimoji="1" lang="ja-JP" altLang="en-US" dirty="0"/>
                         <a:t>タイトル</a:t>
+                      </a:r>
+                    </a:p>
+                  </a:txBody>
+                  <a:tcPr/>
+                </a:tc>
+                <a:tc>
+                  <a:txBody>
+                    <a:bodyPr/>
+                    <a:lstStyle/>
+                    <a:p>
+                      <a:r>
+                        <a:rPr kumimoji="1" lang="ja-JP" altLang="en-US" dirty="0"/>
+                        <a:t>回答</a:t>
                       </a:r>
                     </a:p>
                   </a:txBody>
@@ -5098,6 +5652,53 @@
                         </a:rPr>
                         <a:t>選択問題</a:t>
                       </a:r>
+                    </a:p>
+                  </a:txBody>
+                  <a:tcPr/>
+                </a:tc>
+                <a:tc>
+                  <a:txBody>
+                    <a:bodyPr/>
+                    <a:lstStyle/>
+                    <a:p>
+                      <a:pPr marL="0" marR="0" lvl="0" indent="0" algn="l" defTabSz="914400" rtl="0" eaLnBrk="1" fontAlgn="auto" latinLnBrk="0" hangingPunct="1">
+                        <a:lnSpc>
+                          <a:spcPct val="100000"/>
+                        </a:lnSpc>
+                        <a:spcBef>
+                          <a:spcPts val="0"/>
+                        </a:spcBef>
+                        <a:spcAft>
+                          <a:spcPts val="0"/>
+                        </a:spcAft>
+                        <a:buClrTx/>
+                        <a:buSzTx/>
+                        <a:buFontTx/>
+                        <a:buNone/>
+                        <a:tabLst/>
+                        <a:defRPr/>
+                      </a:pPr>
+                      <a:r>
+                        <a:rPr kumimoji="1" lang="ja-JP" altLang="en-US" sz="1800" b="0" kern="1200" dirty="0">
+                          <a:solidFill>
+                            <a:schemeClr val="dk1"/>
+                          </a:solidFill>
+                          <a:effectLst/>
+                          <a:latin typeface="+mn-lt"/>
+                          <a:ea typeface="+mn-ea"/>
+                          <a:cs typeface="+mn-cs"/>
+                        </a:rPr>
+                        <a:t>東京</a:t>
+                      </a:r>
+                      <a:endParaRPr kumimoji="1" lang="en-US" altLang="ja-JP" sz="1800" b="0" kern="1200" dirty="0">
+                        <a:solidFill>
+                          <a:schemeClr val="dk1"/>
+                        </a:solidFill>
+                        <a:effectLst/>
+                        <a:latin typeface="+mn-lt"/>
+                        <a:ea typeface="+mn-ea"/>
+                        <a:cs typeface="+mn-cs"/>
+                      </a:endParaRPr>
                     </a:p>
                   </a:txBody>
                   <a:tcPr/>
@@ -5243,6 +5844,41 @@
                         <a:tabLst/>
                         <a:defRPr/>
                       </a:pPr>
+                      <a:endParaRPr kumimoji="1" lang="en-US" altLang="ja-JP" sz="1800" b="0" kern="1200" dirty="0">
+                        <a:solidFill>
+                          <a:schemeClr val="dk1"/>
+                        </a:solidFill>
+                        <a:effectLst/>
+                        <a:latin typeface="+mn-lt"/>
+                        <a:ea typeface="+mn-ea"/>
+                        <a:cs typeface="+mn-cs"/>
+                      </a:endParaRPr>
+                    </a:p>
+                  </a:txBody>
+                  <a:tcPr/>
+                </a:tc>
+                <a:tc>
+                  <a:txBody>
+                    <a:bodyPr/>
+                    <a:lstStyle/>
+                    <a:p>
+                      <a:pPr marL="0" marR="0" lvl="0" indent="0" algn="l" defTabSz="914400" rtl="0" eaLnBrk="1" fontAlgn="auto" latinLnBrk="0" hangingPunct="1">
+                        <a:lnSpc>
+                          <a:spcPct val="100000"/>
+                        </a:lnSpc>
+                        <a:spcBef>
+                          <a:spcPts val="0"/>
+                        </a:spcBef>
+                        <a:spcAft>
+                          <a:spcPts val="0"/>
+                        </a:spcAft>
+                        <a:buClrTx/>
+                        <a:buSzTx/>
+                        <a:buFontTx/>
+                        <a:buNone/>
+                        <a:tabLst/>
+                        <a:defRPr/>
+                      </a:pPr>
                       <a:r>
                         <a:rPr lang="ja-JP" altLang="en-US" b="0" i="0" dirty="0">
                           <a:solidFill>
@@ -5349,6 +5985,41 @@
                         <a:tabLst/>
                         <a:defRPr/>
                       </a:pPr>
+                      <a:endParaRPr kumimoji="1" lang="en-US" altLang="ja-JP" sz="1800" b="0" kern="1200" dirty="0">
+                        <a:solidFill>
+                          <a:schemeClr val="dk1"/>
+                        </a:solidFill>
+                        <a:effectLst/>
+                        <a:latin typeface="+mn-lt"/>
+                        <a:ea typeface="+mn-ea"/>
+                        <a:cs typeface="+mn-cs"/>
+                      </a:endParaRPr>
+                    </a:p>
+                  </a:txBody>
+                  <a:tcPr/>
+                </a:tc>
+                <a:tc>
+                  <a:txBody>
+                    <a:bodyPr/>
+                    <a:lstStyle/>
+                    <a:p>
+                      <a:pPr marL="0" marR="0" lvl="0" indent="0" algn="l" defTabSz="914400" rtl="0" eaLnBrk="1" fontAlgn="auto" latinLnBrk="0" hangingPunct="1">
+                        <a:lnSpc>
+                          <a:spcPct val="100000"/>
+                        </a:lnSpc>
+                        <a:spcBef>
+                          <a:spcPts val="0"/>
+                        </a:spcBef>
+                        <a:spcAft>
+                          <a:spcPts val="0"/>
+                        </a:spcAft>
+                        <a:buClrTx/>
+                        <a:buSzTx/>
+                        <a:buFontTx/>
+                        <a:buNone/>
+                        <a:tabLst/>
+                        <a:defRPr/>
+                      </a:pPr>
                       <a:r>
                         <a:rPr kumimoji="1" lang="ja-JP" altLang="en-US" sz="1800" b="0" i="1" kern="1200" dirty="0">
                           <a:solidFill>
@@ -5457,6 +6128,44 @@
                         <a:defRPr/>
                       </a:pPr>
                       <a:r>
+                        <a:rPr kumimoji="1" lang="en-US" altLang="ja-JP" sz="1800" b="0" kern="1200" dirty="0">
+                          <a:solidFill>
+                            <a:schemeClr val="dk1"/>
+                          </a:solidFill>
+                          <a:effectLst/>
+                          <a:latin typeface="+mn-lt"/>
+                          <a:ea typeface="+mn-ea"/>
+                          <a:cs typeface="+mn-cs"/>
+                        </a:rPr>
+                        <a:t>C-D</a:t>
+                      </a:r>
+                    </a:p>
+                  </a:txBody>
+                  <a:tcPr/>
+                </a:tc>
+                <a:tc>
+                  <a:txBody>
+                    <a:bodyPr/>
+                    <a:lstStyle/>
+                    <a:p>
+                      <a:pPr marL="0" marR="0" lvl="0" indent="0" algn="l" defTabSz="914400" rtl="0" eaLnBrk="1" fontAlgn="auto" latinLnBrk="0" hangingPunct="1">
+                        <a:lnSpc>
+                          <a:spcPct val="100000"/>
+                        </a:lnSpc>
+                        <a:spcBef>
+                          <a:spcPts val="0"/>
+                        </a:spcBef>
+                        <a:spcAft>
+                          <a:spcPts val="0"/>
+                        </a:spcAft>
+                        <a:buClrTx/>
+                        <a:buSzTx/>
+                        <a:buFontTx/>
+                        <a:buNone/>
+                        <a:tabLst/>
+                        <a:defRPr/>
+                      </a:pPr>
+                      <a:r>
                         <a:rPr lang="ja-JP" altLang="en-US" b="0" i="0" dirty="0">
                           <a:solidFill>
                             <a:srgbClr val="FF9800"/>
@@ -5563,6 +6272,44 @@
                         <a:defRPr/>
                       </a:pPr>
                       <a:r>
+                        <a:rPr kumimoji="1" lang="en-US" altLang="ja-JP" sz="1800" b="0" kern="1200" dirty="0">
+                          <a:solidFill>
+                            <a:schemeClr val="dk1"/>
+                          </a:solidFill>
+                          <a:effectLst/>
+                          <a:latin typeface="+mn-lt"/>
+                          <a:ea typeface="+mn-ea"/>
+                          <a:cs typeface="+mn-cs"/>
+                        </a:rPr>
+                        <a:t>A,B,C</a:t>
+                      </a:r>
+                    </a:p>
+                  </a:txBody>
+                  <a:tcPr/>
+                </a:tc>
+                <a:tc>
+                  <a:txBody>
+                    <a:bodyPr/>
+                    <a:lstStyle/>
+                    <a:p>
+                      <a:pPr marL="0" marR="0" lvl="0" indent="0" algn="l" defTabSz="914400" rtl="0" eaLnBrk="1" fontAlgn="auto" latinLnBrk="0" hangingPunct="1">
+                        <a:lnSpc>
+                          <a:spcPct val="100000"/>
+                        </a:lnSpc>
+                        <a:spcBef>
+                          <a:spcPts val="0"/>
+                        </a:spcBef>
+                        <a:spcAft>
+                          <a:spcPts val="0"/>
+                        </a:spcAft>
+                        <a:buClrTx/>
+                        <a:buSzTx/>
+                        <a:buFontTx/>
+                        <a:buNone/>
+                        <a:tabLst/>
+                        <a:defRPr/>
+                      </a:pPr>
+                      <a:r>
                         <a:rPr kumimoji="1" lang="en-US" altLang="ja-JP" sz="1800" b="0" i="0" kern="1200" dirty="0">
                           <a:solidFill>
                             <a:schemeClr val="dk1"/>
@@ -5670,6 +6417,53 @@
                         <a:defRPr/>
                       </a:pPr>
                       <a:r>
+                        <a:rPr kumimoji="1" lang="ja-JP" altLang="en-US" sz="1800" b="0" kern="1200" dirty="0">
+                          <a:solidFill>
+                            <a:schemeClr val="dk1"/>
+                          </a:solidFill>
+                          <a:effectLst/>
+                          <a:latin typeface="+mn-lt"/>
+                          <a:ea typeface="+mn-ea"/>
+                          <a:cs typeface="+mn-cs"/>
+                        </a:rPr>
+                        <a:t>富士山</a:t>
+                      </a:r>
+                      <a:endParaRPr kumimoji="1" lang="en-US" altLang="ja-JP" sz="1800" b="0" kern="1200" dirty="0">
+                        <a:solidFill>
+                          <a:schemeClr val="dk1"/>
+                        </a:solidFill>
+                        <a:effectLst/>
+                        <a:latin typeface="+mn-lt"/>
+                        <a:ea typeface="+mn-ea"/>
+                        <a:cs typeface="+mn-cs"/>
+                      </a:endParaRPr>
+                    </a:p>
+                  </a:txBody>
+                  <a:tcPr/>
+                </a:tc>
+                <a:tc>
+                  <a:txBody>
+                    <a:bodyPr/>
+                    <a:lstStyle/>
+                    <a:p>
+                      <a:pPr marL="0" marR="0" lvl="0" indent="0" algn="l" defTabSz="914400" rtl="0" eaLnBrk="1" fontAlgn="auto" latinLnBrk="0" hangingPunct="1">
+                        <a:lnSpc>
+                          <a:spcPct val="100000"/>
+                        </a:lnSpc>
+                        <a:spcBef>
+                          <a:spcPts val="0"/>
+                        </a:spcBef>
+                        <a:spcAft>
+                          <a:spcPts val="0"/>
+                        </a:spcAft>
+                        <a:buClrTx/>
+                        <a:buSzTx/>
+                        <a:buFontTx/>
+                        <a:buNone/>
+                        <a:tabLst/>
+                        <a:defRPr/>
+                      </a:pPr>
+                      <a:r>
                         <a:rPr lang="ja-JP" altLang="en-US" b="0" i="0" dirty="0">
                           <a:solidFill>
                             <a:srgbClr val="FF9800"/>
@@ -5699,6 +6493,580 @@
                   </a:ext>
                 </a:extLst>
               </a:tr>
+              <a:tr h="370840">
+                <a:tc>
+                  <a:txBody>
+                    <a:bodyPr/>
+                    <a:lstStyle/>
+                    <a:p>
+                      <a:pPr algn="ctr"/>
+                      <a:r>
+                        <a:rPr kumimoji="1" lang="en-US" altLang="ja-JP" dirty="0"/>
+                        <a:t>7</a:t>
+                      </a:r>
+                      <a:endParaRPr kumimoji="1" lang="ja-JP" altLang="en-US" dirty="0"/>
+                    </a:p>
+                  </a:txBody>
+                  <a:tcPr/>
+                </a:tc>
+                <a:tc>
+                  <a:txBody>
+                    <a:bodyPr/>
+                    <a:lstStyle/>
+                    <a:p>
+                      <a:pPr marL="0" marR="0" lvl="0" indent="0" algn="l" defTabSz="914400" rtl="0" eaLnBrk="1" fontAlgn="auto" latinLnBrk="0" hangingPunct="1">
+                        <a:lnSpc>
+                          <a:spcPct val="100000"/>
+                        </a:lnSpc>
+                        <a:spcBef>
+                          <a:spcPts val="0"/>
+                        </a:spcBef>
+                        <a:spcAft>
+                          <a:spcPts val="0"/>
+                        </a:spcAft>
+                        <a:buClrTx/>
+                        <a:buSzTx/>
+                        <a:buFontTx/>
+                        <a:buNone/>
+                        <a:tabLst/>
+                        <a:defRPr/>
+                      </a:pPr>
+                      <a:r>
+                        <a:rPr kumimoji="1" lang="ja-JP" altLang="en-US" sz="1800" b="0" kern="1200" dirty="0">
+                          <a:solidFill>
+                            <a:schemeClr val="dk1"/>
+                          </a:solidFill>
+                          <a:effectLst/>
+                          <a:latin typeface="+mn-lt"/>
+                          <a:ea typeface="+mn-ea"/>
+                          <a:cs typeface="+mn-cs"/>
+                        </a:rPr>
+                        <a:t>マッチング問題 </a:t>
+                      </a:r>
+                      <a:r>
+                        <a:rPr kumimoji="1" lang="en-US" altLang="ja-JP" sz="1800" b="0" kern="1200" dirty="0">
+                          <a:solidFill>
+                            <a:schemeClr val="dk1"/>
+                          </a:solidFill>
+                          <a:effectLst/>
+                          <a:latin typeface="+mn-lt"/>
+                          <a:ea typeface="+mn-ea"/>
+                          <a:cs typeface="+mn-cs"/>
+                        </a:rPr>
+                        <a:t>#2</a:t>
+                      </a:r>
+                      <a:endParaRPr kumimoji="1" lang="ja-JP" altLang="en-US" sz="1800" b="0" kern="1200" dirty="0">
+                        <a:solidFill>
+                          <a:schemeClr val="dk1"/>
+                        </a:solidFill>
+                        <a:effectLst/>
+                        <a:latin typeface="+mn-lt"/>
+                        <a:ea typeface="+mn-ea"/>
+                        <a:cs typeface="+mn-cs"/>
+                      </a:endParaRPr>
+                    </a:p>
+                  </a:txBody>
+                  <a:tcPr/>
+                </a:tc>
+                <a:tc>
+                  <a:txBody>
+                    <a:bodyPr/>
+                    <a:lstStyle/>
+                    <a:p>
+                      <a:pPr marL="0" marR="0" lvl="0" indent="0" algn="l" defTabSz="914400" rtl="0" eaLnBrk="1" fontAlgn="auto" latinLnBrk="0" hangingPunct="1">
+                        <a:lnSpc>
+                          <a:spcPct val="100000"/>
+                        </a:lnSpc>
+                        <a:spcBef>
+                          <a:spcPts val="0"/>
+                        </a:spcBef>
+                        <a:spcAft>
+                          <a:spcPts val="0"/>
+                        </a:spcAft>
+                        <a:buClrTx/>
+                        <a:buSzTx/>
+                        <a:buFontTx/>
+                        <a:buNone/>
+                        <a:tabLst/>
+                        <a:defRPr/>
+                      </a:pPr>
+                      <a:r>
+                        <a:rPr kumimoji="1" lang="en-US" altLang="ja-JP" sz="1800" b="0" kern="1200" dirty="0">
+                          <a:solidFill>
+                            <a:schemeClr val="dk1"/>
+                          </a:solidFill>
+                          <a:effectLst/>
+                          <a:latin typeface="+mn-lt"/>
+                          <a:ea typeface="+mn-ea"/>
+                          <a:cs typeface="+mn-cs"/>
+                        </a:rPr>
+                        <a:t>A-B</a:t>
+                      </a:r>
+                    </a:p>
+                  </a:txBody>
+                  <a:tcPr/>
+                </a:tc>
+                <a:tc>
+                  <a:txBody>
+                    <a:bodyPr/>
+                    <a:lstStyle/>
+                    <a:p>
+                      <a:pPr marL="0" marR="0" lvl="0" indent="0" algn="l" defTabSz="914400" rtl="0" eaLnBrk="1" fontAlgn="auto" latinLnBrk="0" hangingPunct="1">
+                        <a:lnSpc>
+                          <a:spcPct val="100000"/>
+                        </a:lnSpc>
+                        <a:spcBef>
+                          <a:spcPts val="0"/>
+                        </a:spcBef>
+                        <a:spcAft>
+                          <a:spcPts val="0"/>
+                        </a:spcAft>
+                        <a:buClrTx/>
+                        <a:buSzTx/>
+                        <a:buFontTx/>
+                        <a:buNone/>
+                        <a:tabLst/>
+                        <a:defRPr/>
+                      </a:pPr>
+                      <a:r>
+                        <a:rPr lang="ja-JP" altLang="en-US" b="0" i="0" dirty="0">
+                          <a:solidFill>
+                            <a:srgbClr val="FF9800"/>
+                          </a:solidFill>
+                          <a:effectLst/>
+                          <a:latin typeface="Noto Sans JP" panose="020B0200000000000000" pitchFamily="50" charset="-128"/>
+                          <a:ea typeface="Noto Sans JP" panose="020B0200000000000000" pitchFamily="50" charset="-128"/>
+                        </a:rPr>
+                        <a:t>未採点</a:t>
+                      </a:r>
+                      <a:endParaRPr kumimoji="1" lang="en-US" altLang="ja-JP" sz="1800" b="0" kern="1200" dirty="0">
+                        <a:solidFill>
+                          <a:schemeClr val="dk1"/>
+                        </a:solidFill>
+                        <a:effectLst/>
+                        <a:latin typeface="+mn-lt"/>
+                        <a:ea typeface="+mn-ea"/>
+                        <a:cs typeface="+mn-cs"/>
+                      </a:endParaRPr>
+                    </a:p>
+                  </a:txBody>
+                  <a:tcPr/>
+                </a:tc>
+                <a:extLst>
+                  <a:ext uri="{0D108BD9-81ED-4DB2-BD59-A6C34878D82A}">
+                    <a16:rowId xmlns:a16="http://schemas.microsoft.com/office/drawing/2014/main" val="452051766"/>
+                  </a:ext>
+                </a:extLst>
+              </a:tr>
+              <a:tr h="370840">
+                <a:tc>
+                  <a:txBody>
+                    <a:bodyPr/>
+                    <a:lstStyle/>
+                    <a:p>
+                      <a:pPr algn="ctr"/>
+                      <a:r>
+                        <a:rPr kumimoji="1" lang="en-US" altLang="ja-JP" dirty="0"/>
+                        <a:t>8</a:t>
+                      </a:r>
+                      <a:endParaRPr kumimoji="1" lang="ja-JP" altLang="en-US" dirty="0"/>
+                    </a:p>
+                  </a:txBody>
+                  <a:tcPr/>
+                </a:tc>
+                <a:tc>
+                  <a:txBody>
+                    <a:bodyPr/>
+                    <a:lstStyle/>
+                    <a:p>
+                      <a:pPr marL="0" marR="0" lvl="0" indent="0" algn="l" defTabSz="914400" rtl="0" eaLnBrk="1" fontAlgn="auto" latinLnBrk="0" hangingPunct="1">
+                        <a:lnSpc>
+                          <a:spcPct val="100000"/>
+                        </a:lnSpc>
+                        <a:spcBef>
+                          <a:spcPts val="0"/>
+                        </a:spcBef>
+                        <a:spcAft>
+                          <a:spcPts val="0"/>
+                        </a:spcAft>
+                        <a:buClrTx/>
+                        <a:buSzTx/>
+                        <a:buFontTx/>
+                        <a:buNone/>
+                        <a:tabLst/>
+                        <a:defRPr/>
+                      </a:pPr>
+                      <a:r>
+                        <a:rPr kumimoji="1" lang="ja-JP" altLang="en-US" sz="1800" b="0" kern="1200" dirty="0">
+                          <a:solidFill>
+                            <a:schemeClr val="dk1"/>
+                          </a:solidFill>
+                          <a:effectLst/>
+                          <a:latin typeface="+mn-lt"/>
+                          <a:ea typeface="+mn-ea"/>
+                          <a:cs typeface="+mn-cs"/>
+                        </a:rPr>
+                        <a:t>インライン選択問題</a:t>
+                      </a:r>
+                      <a:r>
+                        <a:rPr kumimoji="1" lang="en-US" altLang="ja-JP" sz="1800" b="0" kern="1200" dirty="0">
+                          <a:solidFill>
+                            <a:schemeClr val="dk1"/>
+                          </a:solidFill>
+                          <a:effectLst/>
+                          <a:latin typeface="+mn-lt"/>
+                          <a:ea typeface="+mn-ea"/>
+                          <a:cs typeface="+mn-cs"/>
+                        </a:rPr>
+                        <a:t>(</a:t>
+                      </a:r>
+                      <a:r>
+                        <a:rPr kumimoji="1" lang="ja-JP" altLang="en-US" sz="1800" b="0" kern="1200" dirty="0">
+                          <a:solidFill>
+                            <a:schemeClr val="dk1"/>
+                          </a:solidFill>
+                          <a:effectLst/>
+                          <a:latin typeface="+mn-lt"/>
+                          <a:ea typeface="+mn-ea"/>
+                          <a:cs typeface="+mn-cs"/>
+                        </a:rPr>
+                        <a:t>縦書き</a:t>
+                      </a:r>
+                      <a:r>
+                        <a:rPr kumimoji="1" lang="en-US" altLang="ja-JP" sz="1800" b="0" kern="1200" dirty="0">
+                          <a:solidFill>
+                            <a:schemeClr val="dk1"/>
+                          </a:solidFill>
+                          <a:effectLst/>
+                          <a:latin typeface="+mn-lt"/>
+                          <a:ea typeface="+mn-ea"/>
+                          <a:cs typeface="+mn-cs"/>
+                        </a:rPr>
+                        <a:t>)</a:t>
+                      </a:r>
+                      <a:endParaRPr kumimoji="1" lang="ja-JP" altLang="en-US" sz="1800" b="0" kern="1200" dirty="0">
+                        <a:solidFill>
+                          <a:schemeClr val="dk1"/>
+                        </a:solidFill>
+                        <a:effectLst/>
+                        <a:latin typeface="+mn-lt"/>
+                        <a:ea typeface="+mn-ea"/>
+                        <a:cs typeface="+mn-cs"/>
+                      </a:endParaRPr>
+                    </a:p>
+                  </a:txBody>
+                  <a:tcPr/>
+                </a:tc>
+                <a:tc>
+                  <a:txBody>
+                    <a:bodyPr/>
+                    <a:lstStyle/>
+                    <a:p>
+                      <a:pPr marL="0" marR="0" lvl="0" indent="0" algn="l" defTabSz="914400" rtl="0" eaLnBrk="1" fontAlgn="auto" latinLnBrk="0" hangingPunct="1">
+                        <a:lnSpc>
+                          <a:spcPct val="100000"/>
+                        </a:lnSpc>
+                        <a:spcBef>
+                          <a:spcPts val="0"/>
+                        </a:spcBef>
+                        <a:spcAft>
+                          <a:spcPts val="0"/>
+                        </a:spcAft>
+                        <a:buClrTx/>
+                        <a:buSzTx/>
+                        <a:buFontTx/>
+                        <a:buNone/>
+                        <a:tabLst/>
+                        <a:defRPr/>
+                      </a:pPr>
+                      <a:r>
+                        <a:rPr kumimoji="1" lang="ja-JP" altLang="en-US" sz="1800" b="0" kern="1200" dirty="0">
+                          <a:solidFill>
+                            <a:schemeClr val="dk1"/>
+                          </a:solidFill>
+                          <a:effectLst/>
+                          <a:latin typeface="+mn-lt"/>
+                          <a:ea typeface="+mn-ea"/>
+                          <a:cs typeface="+mn-cs"/>
+                        </a:rPr>
+                        <a:t>俳句</a:t>
+                      </a:r>
+                      <a:endParaRPr kumimoji="1" lang="en-US" altLang="ja-JP" sz="1800" b="0" kern="1200" dirty="0">
+                        <a:solidFill>
+                          <a:schemeClr val="dk1"/>
+                        </a:solidFill>
+                        <a:effectLst/>
+                        <a:latin typeface="+mn-lt"/>
+                        <a:ea typeface="+mn-ea"/>
+                        <a:cs typeface="+mn-cs"/>
+                      </a:endParaRPr>
+                    </a:p>
+                  </a:txBody>
+                  <a:tcPr/>
+                </a:tc>
+                <a:tc>
+                  <a:txBody>
+                    <a:bodyPr/>
+                    <a:lstStyle/>
+                    <a:p>
+                      <a:pPr marL="0" marR="0" lvl="0" indent="0" algn="l" defTabSz="914400" rtl="0" eaLnBrk="1" fontAlgn="auto" latinLnBrk="0" hangingPunct="1">
+                        <a:lnSpc>
+                          <a:spcPct val="100000"/>
+                        </a:lnSpc>
+                        <a:spcBef>
+                          <a:spcPts val="0"/>
+                        </a:spcBef>
+                        <a:spcAft>
+                          <a:spcPts val="0"/>
+                        </a:spcAft>
+                        <a:buClrTx/>
+                        <a:buSzTx/>
+                        <a:buFontTx/>
+                        <a:buNone/>
+                        <a:tabLst/>
+                        <a:defRPr/>
+                      </a:pPr>
+                      <a:r>
+                        <a:rPr kumimoji="1" lang="en-US" altLang="ja-JP" sz="1800" b="0" kern="1200" dirty="0">
+                          <a:solidFill>
+                            <a:schemeClr val="dk1"/>
+                          </a:solidFill>
+                          <a:effectLst/>
+                          <a:latin typeface="+mn-lt"/>
+                          <a:ea typeface="+mn-ea"/>
+                          <a:cs typeface="+mn-cs"/>
+                        </a:rPr>
+                        <a:t>1/1 </a:t>
+                      </a:r>
+                      <a:r>
+                        <a:rPr kumimoji="1" lang="ja-JP" altLang="en-US" sz="1800" b="0" kern="1200" dirty="0">
+                          <a:solidFill>
+                            <a:schemeClr val="dk1"/>
+                          </a:solidFill>
+                          <a:effectLst/>
+                          <a:latin typeface="+mn-lt"/>
+                          <a:ea typeface="+mn-ea"/>
+                          <a:cs typeface="+mn-cs"/>
+                        </a:rPr>
+                        <a:t>○</a:t>
+                      </a:r>
+                      <a:endParaRPr kumimoji="1" lang="en-US" altLang="ja-JP" sz="1800" b="0" kern="1200" dirty="0">
+                        <a:solidFill>
+                          <a:schemeClr val="dk1"/>
+                        </a:solidFill>
+                        <a:effectLst/>
+                        <a:latin typeface="+mn-lt"/>
+                        <a:ea typeface="+mn-ea"/>
+                        <a:cs typeface="+mn-cs"/>
+                      </a:endParaRPr>
+                    </a:p>
+                  </a:txBody>
+                  <a:tcPr/>
+                </a:tc>
+                <a:extLst>
+                  <a:ext uri="{0D108BD9-81ED-4DB2-BD59-A6C34878D82A}">
+                    <a16:rowId xmlns:a16="http://schemas.microsoft.com/office/drawing/2014/main" val="1159061260"/>
+                  </a:ext>
+                </a:extLst>
+              </a:tr>
+              <a:tr h="370840">
+                <a:tc>
+                  <a:txBody>
+                    <a:bodyPr/>
+                    <a:lstStyle/>
+                    <a:p>
+                      <a:pPr algn="ctr"/>
+                      <a:r>
+                        <a:rPr kumimoji="1" lang="en-US" altLang="ja-JP" dirty="0"/>
+                        <a:t>9</a:t>
+                      </a:r>
+                      <a:endParaRPr kumimoji="1" lang="ja-JP" altLang="en-US" dirty="0"/>
+                    </a:p>
+                  </a:txBody>
+                  <a:tcPr/>
+                </a:tc>
+                <a:tc>
+                  <a:txBody>
+                    <a:bodyPr/>
+                    <a:lstStyle/>
+                    <a:p>
+                      <a:pPr marL="0" marR="0" lvl="0" indent="0" algn="l" defTabSz="914400" rtl="0" eaLnBrk="1" fontAlgn="auto" latinLnBrk="0" hangingPunct="1">
+                        <a:lnSpc>
+                          <a:spcPct val="100000"/>
+                        </a:lnSpc>
+                        <a:spcBef>
+                          <a:spcPts val="0"/>
+                        </a:spcBef>
+                        <a:spcAft>
+                          <a:spcPts val="0"/>
+                        </a:spcAft>
+                        <a:buClrTx/>
+                        <a:buSzTx/>
+                        <a:buFontTx/>
+                        <a:buNone/>
+                        <a:tabLst/>
+                        <a:defRPr/>
+                      </a:pPr>
+                      <a:r>
+                        <a:rPr kumimoji="1" lang="ja-JP" altLang="en-US" sz="1800" b="0" kern="1200" dirty="0">
+                          <a:solidFill>
+                            <a:schemeClr val="dk1"/>
+                          </a:solidFill>
+                          <a:effectLst/>
+                          <a:latin typeface="+mn-lt"/>
+                          <a:ea typeface="+mn-ea"/>
+                          <a:cs typeface="+mn-cs"/>
+                        </a:rPr>
+                        <a:t>テキスト入力問題</a:t>
+                      </a:r>
+                      <a:r>
+                        <a:rPr kumimoji="1" lang="en-US" altLang="ja-JP" sz="1800" b="0" kern="1200" dirty="0">
+                          <a:solidFill>
+                            <a:schemeClr val="dk1"/>
+                          </a:solidFill>
+                          <a:effectLst/>
+                          <a:latin typeface="+mn-lt"/>
+                          <a:ea typeface="+mn-ea"/>
+                          <a:cs typeface="+mn-cs"/>
+                        </a:rPr>
+                        <a:t>(</a:t>
+                      </a:r>
+                      <a:r>
+                        <a:rPr kumimoji="1" lang="ja-JP" altLang="en-US" sz="1800" b="0" kern="1200" dirty="0">
+                          <a:solidFill>
+                            <a:schemeClr val="dk1"/>
+                          </a:solidFill>
+                          <a:effectLst/>
+                          <a:latin typeface="+mn-lt"/>
+                          <a:ea typeface="+mn-ea"/>
+                          <a:cs typeface="+mn-cs"/>
+                        </a:rPr>
+                        <a:t>縦書き</a:t>
+                      </a:r>
+                      <a:r>
+                        <a:rPr kumimoji="1" lang="en-US" altLang="ja-JP" sz="1800" b="0" kern="1200" dirty="0">
+                          <a:solidFill>
+                            <a:schemeClr val="dk1"/>
+                          </a:solidFill>
+                          <a:effectLst/>
+                          <a:latin typeface="+mn-lt"/>
+                          <a:ea typeface="+mn-ea"/>
+                          <a:cs typeface="+mn-cs"/>
+                        </a:rPr>
+                        <a:t>)</a:t>
+                      </a:r>
+                      <a:endParaRPr kumimoji="1" lang="ja-JP" altLang="en-US" sz="1800" b="0" kern="1200" dirty="0">
+                        <a:solidFill>
+                          <a:schemeClr val="dk1"/>
+                        </a:solidFill>
+                        <a:effectLst/>
+                        <a:latin typeface="+mn-lt"/>
+                        <a:ea typeface="+mn-ea"/>
+                        <a:cs typeface="+mn-cs"/>
+                      </a:endParaRPr>
+                    </a:p>
+                  </a:txBody>
+                  <a:tcPr/>
+                </a:tc>
+                <a:tc>
+                  <a:txBody>
+                    <a:bodyPr/>
+                    <a:lstStyle/>
+                    <a:p>
+                      <a:pPr marL="0" marR="0" lvl="0" indent="0" algn="l" defTabSz="914400" rtl="0" eaLnBrk="1" fontAlgn="auto" latinLnBrk="0" hangingPunct="1">
+                        <a:lnSpc>
+                          <a:spcPct val="100000"/>
+                        </a:lnSpc>
+                        <a:spcBef>
+                          <a:spcPts val="0"/>
+                        </a:spcBef>
+                        <a:spcAft>
+                          <a:spcPts val="0"/>
+                        </a:spcAft>
+                        <a:buClrTx/>
+                        <a:buSzTx/>
+                        <a:buFontTx/>
+                        <a:buNone/>
+                        <a:tabLst/>
+                        <a:defRPr/>
+                      </a:pPr>
+                      <a:r>
+                        <a:rPr kumimoji="1" lang="ja-JP" altLang="en-US" sz="1800" b="0" kern="1200" dirty="0">
+                          <a:solidFill>
+                            <a:schemeClr val="dk1"/>
+                          </a:solidFill>
+                          <a:effectLst/>
+                          <a:latin typeface="+mn-lt"/>
+                          <a:ea typeface="+mn-ea"/>
+                          <a:cs typeface="+mn-cs"/>
+                        </a:rPr>
+                        <a:t>うま</a:t>
+                      </a:r>
+                      <a:endParaRPr kumimoji="1" lang="en-US" altLang="ja-JP" sz="1800" b="0" kern="1200" dirty="0">
+                        <a:solidFill>
+                          <a:schemeClr val="dk1"/>
+                        </a:solidFill>
+                        <a:effectLst/>
+                        <a:latin typeface="+mn-lt"/>
+                        <a:ea typeface="+mn-ea"/>
+                        <a:cs typeface="+mn-cs"/>
+                      </a:endParaRPr>
+                    </a:p>
+                  </a:txBody>
+                  <a:tcPr/>
+                </a:tc>
+                <a:tc>
+                  <a:txBody>
+                    <a:bodyPr/>
+                    <a:lstStyle/>
+                    <a:p>
+                      <a:pPr marL="0" marR="0" lvl="0" indent="0" algn="l" defTabSz="914400" rtl="0" eaLnBrk="1" fontAlgn="auto" latinLnBrk="0" hangingPunct="1">
+                        <a:lnSpc>
+                          <a:spcPct val="100000"/>
+                        </a:lnSpc>
+                        <a:spcBef>
+                          <a:spcPts val="0"/>
+                        </a:spcBef>
+                        <a:spcAft>
+                          <a:spcPts val="0"/>
+                        </a:spcAft>
+                        <a:buClrTx/>
+                        <a:buSzTx/>
+                        <a:buFontTx/>
+                        <a:buNone/>
+                        <a:tabLst/>
+                        <a:defRPr/>
+                      </a:pPr>
+                      <a:r>
+                        <a:rPr lang="ja-JP" altLang="en-US" b="0" i="0" dirty="0">
+                          <a:solidFill>
+                            <a:srgbClr val="FF9800"/>
+                          </a:solidFill>
+                          <a:effectLst/>
+                          <a:latin typeface="Noto Sans JP" panose="020B0200000000000000" pitchFamily="50" charset="-128"/>
+                          <a:ea typeface="Noto Sans JP" panose="020B0200000000000000" pitchFamily="50" charset="-128"/>
+                        </a:rPr>
+                        <a:t>未採点</a:t>
+                      </a:r>
+                      <a:endParaRPr kumimoji="1" lang="en-US" altLang="ja-JP" sz="1800" b="0" kern="1200" dirty="0">
+                        <a:solidFill>
+                          <a:schemeClr val="dk1"/>
+                        </a:solidFill>
+                        <a:effectLst/>
+                        <a:latin typeface="+mn-lt"/>
+                        <a:ea typeface="+mn-ea"/>
+                        <a:cs typeface="+mn-cs"/>
+                      </a:endParaRPr>
+                    </a:p>
+                  </a:txBody>
+                  <a:tcPr/>
+                </a:tc>
+                <a:extLst>
+                  <a:ext uri="{0D108BD9-81ED-4DB2-BD59-A6C34878D82A}">
+                    <a16:rowId xmlns:a16="http://schemas.microsoft.com/office/drawing/2014/main" val="1057388764"/>
+                  </a:ext>
+                </a:extLst>
+              </a:tr>
             </a:tbl>
           </a:graphicData>
         </a:graphic>
@@ -5717,7 +7085,7 @@
         </p:nvSpPr>
         <p:spPr>
           <a:xfrm>
-            <a:off x="3048856" y="1384211"/>
+            <a:off x="3048856" y="942424"/>
             <a:ext cx="6097712" cy="1443985"/>
           </a:xfrm>
           <a:prstGeom prst="rect">
@@ -5765,7 +7133,7 @@
                 <a:latin typeface="Noto Sans JP" panose="020B0200000000000000" pitchFamily="50" charset="-128"/>
                 <a:ea typeface="Noto Sans JP" panose="020B0200000000000000" pitchFamily="50" charset="-128"/>
               </a:rPr>
-              <a:t>1</a:t>
+              <a:t>2</a:t>
             </a:r>
             <a:r>
               <a:rPr lang="en-US" altLang="ja-JP" b="0" i="0" dirty="0">
@@ -5776,7 +7144,7 @@
                 <a:latin typeface="Noto Sans JP" panose="020B0200000000000000" pitchFamily="50" charset="-128"/>
                 <a:ea typeface="Noto Sans JP" panose="020B0200000000000000" pitchFamily="50" charset="-128"/>
               </a:rPr>
-              <a:t>/2</a:t>
+              <a:t>/3</a:t>
             </a:r>
             <a:r>
               <a:rPr lang="ja-JP" altLang="en-US" b="0" i="0" dirty="0">
@@ -5825,7 +7193,7 @@
                 <a:latin typeface="Noto Sans JP" panose="020B0200000000000000" pitchFamily="50" charset="-128"/>
                 <a:ea typeface="Noto Sans JP" panose="020B0200000000000000" pitchFamily="50" charset="-128"/>
               </a:rPr>
-              <a:t>: 50%</a:t>
+              <a:t>: 67%</a:t>
             </a:r>
           </a:p>
           <a:p>
@@ -5866,7 +7234,7 @@
                 <a:latin typeface="Noto Sans JP" panose="020B0200000000000000" pitchFamily="50" charset="-128"/>
                 <a:ea typeface="Noto Sans JP" panose="020B0200000000000000" pitchFamily="50" charset="-128"/>
               </a:rPr>
-              <a:t>: 2</a:t>
+              <a:t>: 6</a:t>
             </a:r>
             <a:r>
               <a:rPr lang="ja-JP" altLang="en-US" b="0" i="0" dirty="0">

</xml_diff>

<commit_message>
feat: update UI design documents for clarity and consistency
</commit_message>
<xml_diff>
--- a/docs/UI-Design.pptx
+++ b/docs/UI-Design.pptx
@@ -5139,12 +5139,18 @@
         </p:nvSpPr>
         <p:spPr>
           <a:xfrm>
-            <a:off x="2578813" y="4161034"/>
-            <a:ext cx="1210588" cy="400110"/>
+            <a:off x="2599361" y="4082541"/>
+            <a:ext cx="1210588" cy="587873"/>
           </a:xfrm>
           <a:prstGeom prst="rect">
             <a:avLst/>
           </a:prstGeom>
+          <a:solidFill>
+            <a:srgbClr val="F5F5F5"/>
+          </a:solidFill>
+          <a:ln>
+            <a:noFill/>
+          </a:ln>
         </p:spPr>
         <p:style>
           <a:lnRef idx="2">
@@ -5161,13 +5167,13 @@
           </a:fontRef>
         </p:style>
         <p:txBody>
-          <a:bodyPr wrap="none" rtlCol="0">
-            <a:spAutoFit/>
+          <a:bodyPr wrap="none" rtlCol="0" anchor="ctr">
+            <a:noAutofit/>
           </a:bodyPr>
           <a:lstStyle/>
           <a:p>
             <a:r>
-              <a:rPr kumimoji="1" lang="ja-JP" altLang="en-US" sz="2000" dirty="0"/>
+              <a:rPr kumimoji="1" lang="ja-JP" altLang="en-US" sz="2000" b="1" dirty="0"/>
               <a:t>回答済：</a:t>
             </a:r>
           </a:p>
@@ -5413,6 +5419,98 @@
               <a:t>不正解。正解は「東京」です。</a:t>
             </a:r>
             <a:endParaRPr kumimoji="1" lang="ja-JP" altLang="en-US" dirty="0"/>
+          </a:p>
+        </p:txBody>
+      </p:sp>
+      <p:sp>
+        <p:nvSpPr>
+          <p:cNvPr id="3" name="テキスト ボックス 2">
+            <a:extLst>
+              <a:ext uri="{FF2B5EF4-FFF2-40B4-BE49-F238E27FC236}">
+                <a16:creationId xmlns:a16="http://schemas.microsoft.com/office/drawing/2014/main" id="{3350E07B-2C56-0290-931C-083F70BB136C}"/>
+              </a:ext>
+            </a:extLst>
+          </p:cNvPr>
+          <p:cNvSpPr txBox="1"/>
+          <p:nvPr/>
+        </p:nvSpPr>
+        <p:spPr>
+          <a:xfrm>
+            <a:off x="2567086" y="4082541"/>
+            <a:ext cx="1337939" cy="587873"/>
+          </a:xfrm>
+          <a:prstGeom prst="rect">
+            <a:avLst/>
+          </a:prstGeom>
+          <a:solidFill>
+            <a:srgbClr val="F5F5F5"/>
+          </a:solidFill>
+          <a:ln>
+            <a:noFill/>
+          </a:ln>
+        </p:spPr>
+        <p:style>
+          <a:lnRef idx="2">
+            <a:schemeClr val="dk1"/>
+          </a:lnRef>
+          <a:fillRef idx="1">
+            <a:schemeClr val="lt1"/>
+          </a:fillRef>
+          <a:effectRef idx="0">
+            <a:schemeClr val="dk1"/>
+          </a:effectRef>
+          <a:fontRef idx="minor">
+            <a:schemeClr val="dk1"/>
+          </a:fontRef>
+        </p:style>
+        <p:txBody>
+          <a:bodyPr wrap="none" rtlCol="0" anchor="ctr">
+            <a:noAutofit/>
+          </a:bodyPr>
+          <a:lstStyle/>
+          <a:p>
+            <a:r>
+              <a:rPr kumimoji="1" lang="ja-JP" altLang="en-US" sz="2000" b="1" dirty="0"/>
+              <a:t>回答済：</a:t>
+            </a:r>
+          </a:p>
+        </p:txBody>
+      </p:sp>
+      <p:sp>
+        <p:nvSpPr>
+          <p:cNvPr id="7" name="テキスト ボックス 6">
+            <a:extLst>
+              <a:ext uri="{FF2B5EF4-FFF2-40B4-BE49-F238E27FC236}">
+                <a16:creationId xmlns:a16="http://schemas.microsoft.com/office/drawing/2014/main" id="{3C6D2BDE-D602-E5CD-B8CC-54D9F1188483}"/>
+              </a:ext>
+            </a:extLst>
+          </p:cNvPr>
+          <p:cNvSpPr txBox="1"/>
+          <p:nvPr/>
+        </p:nvSpPr>
+        <p:spPr>
+          <a:xfrm>
+            <a:off x="10132901" y="4234844"/>
+            <a:ext cx="284052" cy="307777"/>
+          </a:xfrm>
+          <a:prstGeom prst="rect">
+            <a:avLst/>
+          </a:prstGeom>
+          <a:solidFill>
+            <a:srgbClr val="F5F5F5"/>
+          </a:solidFill>
+        </p:spPr>
+        <p:txBody>
+          <a:bodyPr wrap="none" rtlCol="0">
+            <a:spAutoFit/>
+          </a:bodyPr>
+          <a:lstStyle/>
+          <a:p>
+            <a:r>
+              <a:rPr kumimoji="1" lang="en-US" altLang="ja-JP" sz="1400" dirty="0"/>
+              <a:t>0</a:t>
+            </a:r>
+            <a:endParaRPr kumimoji="1" lang="ja-JP" altLang="en-US" sz="1400" dirty="0"/>
           </a:p>
         </p:txBody>
       </p:sp>

</xml_diff>